<commit_message>
Add presenter script to Mystery Shopper Sep 2026 deck
Short per-slide script, added as speaker notes in the deck and as a
standalone Presenter_Script.md.

Co-Authored-By: Claude Opus 5.5 <noreply@anthropic.com>
Claude-Session: https://claude.ai/code/session_01F9G2pLbYYZsGUXfCpjiAv1
</commit_message>
<xml_diff>
--- a/Mystery Shopper Sep 2026/UR_Klinik_Mystery_Shopper_Sep2026_Redesign.pptx
+++ b/Mystery Shopper Sep 2026/UR_Klinik_Mystery_Shopper_Sep2026_Redesign.pptx
@@ -1775,7 +1775,7 @@
           <a:p>
             <a:r>
               <a:rPr lang="en-US" dirty="0"/>
-              <a:t/>
+              <a:t>Good morning everyone. Today I'll share our Mystery Shopper results for September 2026. One shopper visited each of our 3 outlets. Puchong got our top score at 93.25, Greenlane got 77.5, and Cheras Leisure Mall got 66.75.</a:t>
             </a:r>
             <a:endParaRPr lang="en-US" dirty="0"/>
           </a:p>
@@ -1863,7 +1863,7 @@
           <a:p>
             <a:r>
               <a:rPr lang="en-US" dirty="0"/>
-              <a:t/>
+              <a:t>Here's a quick look at all three. On top is what each shopper loved, and at the bottom is where we can grow. The good news: every shopper found something they liked. One thing to note: price came up in all three visits.</a:t>
             </a:r>
             <a:endParaRPr lang="en-US" dirty="0"/>
           </a:p>
@@ -1951,7 +1951,7 @@
           <a:p>
             <a:r>
               <a:rPr lang="en-US" dirty="0"/>
-              <a:t/>
+              <a:t>Greenlane scored 77.5. The shopper was impressed by our equipment and loved the small details: the travel set gift, the warm red date tea, and a clean, tidy clinic. Sylvin was praised for being very friendly. Well done, Sylvin! To grow: the shopper wanted the AI analysis to feel more interactive, with more of a 'wow'. They also hoped the visit could be shorter, within 2 hours, and felt the price could be more accessible.</a:t>
             </a:r>
             <a:endParaRPr lang="en-US" dirty="0"/>
           </a:p>
@@ -2039,7 +2039,7 @@
           <a:p>
             <a:r>
               <a:rPr lang="en-US" dirty="0"/>
-              <a:t/>
+              <a:t>Puchong is our top score at 93.25. Congratulations, team! The shopper said the overall experience was very good. The doctor explained everything clearly, and the therapist was friendly and caring. Just a few small touches: during treatment, remind customers of simple actions like turning the head. After the bright light, help their eyes adjust before they look in the mirror. And the price may feel high for some customers.</a:t>
             </a:r>
             <a:endParaRPr lang="en-US" dirty="0"/>
           </a:p>
@@ -2127,7 +2127,7 @@
           <a:p>
             <a:r>
               <a:rPr lang="en-US" dirty="0"/>
-              <a:t/>
+              <a:t>Cheras Leisure Mall scored 66.75. The good part: the customer was happy with the result, and her skin looked brighter. Where we can improve: she felt pushed to buy products or packages, and the price felt too high. She also hoped for less waiting and a quieter corridor. And she prefers WhatsApp messages instead of phone calls.</a:t>
             </a:r>
             <a:endParaRPr lang="en-US" dirty="0"/>
           </a:p>
@@ -2215,7 +2215,7 @@
           <a:p>
             <a:r>
               <a:rPr lang="en-US" dirty="0"/>
-              <a:t/>
+              <a:t>In one line each: Greenlane, impressive technology and thoughtful details. Puchong, clear explanation and caring treatment. Cheras, a good visible result. Please take the improvement points back to your team.</a:t>
             </a:r>
             <a:endParaRPr lang="en-US" dirty="0"/>
           </a:p>
@@ -2303,7 +2303,7 @@
           <a:p>
             <a:r>
               <a:rPr lang="en-US" dirty="0"/>
-              <a:t/>
+              <a:t>Here are some of the shoppers' own words, with English translations. (Read one or two out loud.)</a:t>
             </a:r>
             <a:endParaRPr lang="en-US" dirty="0"/>
           </a:p>
@@ -2391,7 +2391,7 @@
           <a:p>
             <a:r>
               <a:rPr lang="en-US" dirty="0"/>
-              <a:t/>
+              <a:t>Thank you, team. Our shoppers remembered the warm welcome, the clear explanations and the caring hands. Let's keep that going, one visit at a time. Any questions?</a:t>
             </a:r>
             <a:endParaRPr lang="en-US" dirty="0"/>
           </a:p>

</xml_diff>

<commit_message>
Add Chinese presenter script to Mystery Shopper Sep 2026 deck
Chinese version saved as Presenter_Script_CN.md and added below the
English text in each slide's speaker notes.

Co-Authored-By: Claude Opus 5.5 <noreply@anthropic.com>
Claude-Session: https://claude.ai/code/session_01F9G2pLbYYZsGUXfCpjiAv1
</commit_message>
<xml_diff>
--- a/Mystery Shopper Sep 2026/UR_Klinik_Mystery_Shopper_Sep2026_Redesign.pptx
+++ b/Mystery Shopper Sep 2026/UR_Klinik_Mystery_Shopper_Sep2026_Redesign.pptx
@@ -1775,7 +1775,9 @@
           <a:p>
             <a:r>
               <a:rPr lang="en-US" dirty="0"/>
-              <a:t>Good morning everyone. Today I'll share our Mystery Shopper results for September 2026. One shopper visited each of our 3 outlets. Puchong got our top score at 93.25, Greenlane got 77.5, and Cheras Leisure Mall got 66.75.</a:t>
+              <a:t>Good morning everyone. Today I'll share our Mystery Shopper results for September 2026. One shopper visited each of our 3 outlets. Puchong got our top score at 93.25, Greenlane got 77.5, and Cheras Leisure Mall got 66.75.
+中文：
+大家早上好。今天跟大家分享 2026 年 9 月的神秘顾客（Mystery Shopper）结果。这次每间分店都有一位神秘顾客到访，一共 3 间分店。Puchong 拿到本月最高分 93.25，Greenlane 是 77.5，Cheras Leisure Mall 是 66.75。</a:t>
             </a:r>
             <a:endParaRPr lang="en-US" dirty="0"/>
           </a:p>
@@ -1863,7 +1865,9 @@
           <a:p>
             <a:r>
               <a:rPr lang="en-US" dirty="0"/>
-              <a:t>Here's a quick look at all three. On top is what each shopper loved, and at the bottom is where we can grow. The good news: every shopper found something they liked. One thing to note: price came up in all three visits.</a:t>
+              <a:t>Here's a quick look at all three. On top is what each shopper loved, and at the bottom is where we can grow. The good news: every shopper found something they liked. One thing to note: price came up in all three visits.
+中文：
+先快速看一下三间分店。上面是顾客喜欢的地方，下面是我们可以进步的地方。好消息是，每位顾客都有喜欢的地方。有一点要留意：三次到访，顾客都有提到价格。</a:t>
             </a:r>
             <a:endParaRPr lang="en-US" dirty="0"/>
           </a:p>
@@ -1951,7 +1955,9 @@
           <a:p>
             <a:r>
               <a:rPr lang="en-US" dirty="0"/>
-              <a:t>Greenlane scored 77.5. The shopper was impressed by our equipment and loved the small details: the travel set gift, the warm red date tea, and a clean, tidy clinic. Sylvin was praised for being very friendly. Well done, Sylvin! To grow: the shopper wanted the AI analysis to feel more interactive, with more of a 'wow'. They also hoped the visit could be shorter, within 2 hours, and felt the price could be more accessible.</a:t>
+              <a:t>Greenlane scored 77.5. The shopper was impressed by our equipment and loved the small details: the travel set gift, the warm red date tea, and a clean, tidy clinic. Sylvin was praised for being very friendly. Well done, Sylvin! To grow: the shopper wanted the AI analysis to feel more interactive, with more of a 'wow'. They also hoped the visit could be shorter, within 2 hours, and felt the price could be more accessible.
+中文：
+Greenlane 拿到 77.5 分。顾客对我们的仪器印象很深，也很喜欢一些小细节：旅行套装礼物、暖暖的红枣茶，还有干净整齐的环境。Sylvin 也被称赞很有亲和力，做得好，Sylvin！可以进步的地方：顾客希望 AI 分析可以更互动，多一点“wow”的感觉。顾客也希望整个流程可以短一点，最好在 2 小时内完成，价格也可以更亲民一些。</a:t>
             </a:r>
             <a:endParaRPr lang="en-US" dirty="0"/>
           </a:p>
@@ -2039,7 +2045,9 @@
           <a:p>
             <a:r>
               <a:rPr lang="en-US" dirty="0"/>
-              <a:t>Puchong is our top score at 93.25. Congratulations, team! The shopper said the overall experience was very good. The doctor explained everything clearly, and the therapist was friendly and caring. Just a few small touches: during treatment, remind customers of simple actions like turning the head. After the bright light, help their eyes adjust before they look in the mirror. And the price may feel high for some customers.</a:t>
+              <a:t>Puchong is our top score at 93.25. Congratulations, team! The shopper said the overall experience was very good. The doctor explained everything clearly, and the therapist was friendly and caring. Just a few small touches: during treatment, remind customers of simple actions like turning the head. After the bright light, help their eyes adjust before they look in the mirror. And the price may feel high for some customers.
+中文：
+Puchong 是本月最高分，93.25 分，恭喜团队！顾客说整体体验非常好。医生解释得很清楚，护理师也很友善、很贴心。只有几个小细节可以加强：护理过程中，提醒顾客一些简单动作，比如转头；做完强光护理后，先让顾客的眼睛慢慢适应，再照镜子；还有，价格对一般顾客来说可能偏高。</a:t>
             </a:r>
             <a:endParaRPr lang="en-US" dirty="0"/>
           </a:p>
@@ -2127,7 +2135,9 @@
           <a:p>
             <a:r>
               <a:rPr lang="en-US" dirty="0"/>
-              <a:t>Cheras Leisure Mall scored 66.75. The good part: the customer was happy with the result, and her skin looked brighter. Where we can improve: she felt pushed to buy products or packages, and the price felt too high. She also hoped for less waiting and a quieter corridor. And she prefers WhatsApp messages instead of phone calls.</a:t>
+              <a:t>Cheras Leisure Mall scored 66.75. The good part: the customer was happy with the result, and her skin looked brighter. Where we can improve: she felt pushed to buy products or packages, and the price felt too high. She also hoped for less waiting and a quieter corridor. And she prefers WhatsApp messages instead of phone calls.
+中文：
+Cheras Leisure Mall 拿到 66.75 分。好的地方是，顾客对效果很满意，觉得皮肤变亮了。需要改进的地方：顾客觉得被推销产品和配套，也觉得价格负担不起。她也希望等待时间少一点、走廊安静一点。另外，她比较喜欢用 WhatsApp 联系，而不是直接打电话。</a:t>
             </a:r>
             <a:endParaRPr lang="en-US" dirty="0"/>
           </a:p>
@@ -2215,7 +2225,9 @@
           <a:p>
             <a:r>
               <a:rPr lang="en-US" dirty="0"/>
-              <a:t>In one line each: Greenlane, impressive technology and thoughtful details. Puchong, clear explanation and caring treatment. Cheras, a good visible result. Please take the improvement points back to your team.</a:t>
+              <a:t>In one line each: Greenlane, impressive technology and thoughtful details. Puchong, clear explanation and caring treatment. Cheras, a good visible result. Please take the improvement points back to your team.
+中文：
+每间分店用一句话总结：Greenlane，先进的科技加上贴心的细节；Puchong，清楚的讲解加上用心的护理；Cheras，看得见的效果。请大家把需要改进的地方带回去跟团队分享。</a:t>
             </a:r>
             <a:endParaRPr lang="en-US" dirty="0"/>
           </a:p>
@@ -2303,7 +2315,9 @@
           <a:p>
             <a:r>
               <a:rPr lang="en-US" dirty="0"/>
-              <a:t>Here are some of the shoppers' own words, with English translations. (Read one or two out loud.)</a:t>
+              <a:t>Here are some of the shoppers' own words, with English translations. (Read one or two out loud.)
+中文：
+这里是几位顾客的原话，也附上了英文翻译。（挑一两句念出来。）</a:t>
             </a:r>
             <a:endParaRPr lang="en-US" dirty="0"/>
           </a:p>
@@ -2391,7 +2405,9 @@
           <a:p>
             <a:r>
               <a:rPr lang="en-US" dirty="0"/>
-              <a:t>Thank you, team. Our shoppers remembered the warm welcome, the clear explanations and the caring hands. Let's keep that going, one visit at a time. Any questions?</a:t>
+              <a:t>Thank you, team. Our shoppers remembered the warm welcome, the clear explanations and the caring hands. Let's keep that going, one visit at a time. Any questions?
+中文：
+谢谢大家！顾客记得的是我们热情的招待、清楚的讲解和用心的护理。让我们继续保持，每一次到访都用心做好。大家有什么问题吗？</a:t>
             </a:r>
             <a:endParaRPr lang="en-US" dirty="0"/>
           </a:p>

</xml_diff>